<commit_message>
Add Financial Forecasting skill, update Cowork docs and CLAUDE.md
- Add Financial Forecasting SKILL.md for time series forecasting (ARIMA/Prophet)
- Expand README-BCowork.md with skills, plugins, and data analysis demo docs
- Update Prompt Library with revised data analysis plugin workflow
- Update Claude Cowork slides (pptx)
- Tighten CLAUDE.md: fix README numbering, expand Skills/Materials sections, simplify MCP docs, add GitHub MCP server

Co-Authored-By: Claude Sonnet 4.6 <noreply@anthropic.com>
</commit_message>
<xml_diff>
--- a/Claude Masterclass Materials/Module 2 - Claude Cowork/Claude Cowork.pptx
+++ b/Claude Masterclass Materials/Module 2 - Claude Cowork/Claude Cowork.pptx
@@ -3249,7 +3249,7 @@
           <a:p>
             <a:fld id="{25C911D1-6589-4D4A-810A-D1CB24D30600}" type="datetimeFigureOut">
               <a:rPr lang="en-US" smtClean="0"/>
-              <a:t>3/26/2026</a:t>
+              <a:t>3/31/2026</a:t>
             </a:fld>
             <a:endParaRPr lang="en-US"/>
           </a:p>
@@ -4019,7 +4019,7 @@
           <a:p>
             <a:fld id="{FD8C779B-2DF9-41ED-BDF6-094A96BB5831}" type="datetime1">
               <a:rPr lang="en-US" smtClean="0"/>
-              <a:t>3/26/2026</a:t>
+              <a:t>3/31/2026</a:t>
             </a:fld>
             <a:endParaRPr lang="en-US"/>
           </a:p>
@@ -4220,7 +4220,7 @@
           <a:p>
             <a:fld id="{2050BBC8-E478-43C9-A4F1-EDD4F72015DC}" type="datetime1">
               <a:rPr lang="en-US" smtClean="0"/>
-              <a:t>3/26/2026</a:t>
+              <a:t>3/31/2026</a:t>
             </a:fld>
             <a:endParaRPr lang="en-US"/>
           </a:p>
@@ -4431,7 +4431,7 @@
           <a:p>
             <a:fld id="{04321BB6-29D9-437A-B4EB-C48447ACC5C8}" type="datetime1">
               <a:rPr lang="en-US" smtClean="0"/>
-              <a:t>3/26/2026</a:t>
+              <a:t>3/31/2026</a:t>
             </a:fld>
             <a:endParaRPr lang="en-US"/>
           </a:p>
@@ -4632,7 +4632,7 @@
           <a:p>
             <a:fld id="{CEC83053-3D74-4D22-89B3-9024BA4F287F}" type="datetime1">
               <a:rPr lang="en-US" smtClean="0"/>
-              <a:t>3/26/2026</a:t>
+              <a:t>3/31/2026</a:t>
             </a:fld>
             <a:endParaRPr lang="en-US"/>
           </a:p>
@@ -4910,7 +4910,7 @@
           <a:p>
             <a:fld id="{37A6BCF6-84B7-49AA-A69F-35D95B9487C2}" type="datetime1">
               <a:rPr lang="en-US" smtClean="0"/>
-              <a:t>3/26/2026</a:t>
+              <a:t>3/31/2026</a:t>
             </a:fld>
             <a:endParaRPr lang="en-US"/>
           </a:p>
@@ -5178,7 +5178,7 @@
           <a:p>
             <a:fld id="{DFF119D7-9FF6-460F-A484-0C02884C819E}" type="datetime1">
               <a:rPr lang="en-US" smtClean="0"/>
-              <a:t>3/26/2026</a:t>
+              <a:t>3/31/2026</a:t>
             </a:fld>
             <a:endParaRPr lang="en-US"/>
           </a:p>
@@ -5593,7 +5593,7 @@
           <a:p>
             <a:fld id="{00D3F2F9-9F59-4926-81E1-5AE7B5F13616}" type="datetime1">
               <a:rPr lang="en-US" smtClean="0"/>
-              <a:t>3/26/2026</a:t>
+              <a:t>3/31/2026</a:t>
             </a:fld>
             <a:endParaRPr lang="en-US"/>
           </a:p>
@@ -5737,7 +5737,7 @@
           <a:p>
             <a:fld id="{2425E9FE-B00F-4787-941B-81F5C60BF956}" type="datetime1">
               <a:rPr lang="en-US" smtClean="0"/>
-              <a:t>3/26/2026</a:t>
+              <a:t>3/31/2026</a:t>
             </a:fld>
             <a:endParaRPr lang="en-US"/>
           </a:p>
@@ -5853,7 +5853,7 @@
           <a:p>
             <a:fld id="{A83063A8-27AB-4485-9BAB-385A926DB554}" type="datetime1">
               <a:rPr lang="en-US" smtClean="0"/>
-              <a:t>3/26/2026</a:t>
+              <a:t>3/31/2026</a:t>
             </a:fld>
             <a:endParaRPr lang="en-US"/>
           </a:p>
@@ -6167,7 +6167,7 @@
           <a:p>
             <a:fld id="{B91EE9DF-0ED6-4B61-A1FD-8DD75280FE01}" type="datetime1">
               <a:rPr lang="en-US" smtClean="0"/>
-              <a:t>3/26/2026</a:t>
+              <a:t>3/31/2026</a:t>
             </a:fld>
             <a:endParaRPr lang="en-US"/>
           </a:p>
@@ -6458,7 +6458,7 @@
           <a:p>
             <a:fld id="{0C6B4C01-5047-4D04-A79D-6D96B1DB76E2}" type="datetime1">
               <a:rPr lang="en-US" smtClean="0"/>
-              <a:t>3/26/2026</a:t>
+              <a:t>3/31/2026</a:t>
             </a:fld>
             <a:endParaRPr lang="en-US"/>
           </a:p>
@@ -6702,7 +6702,7 @@
           <a:p>
             <a:fld id="{FA729903-C382-4170-95C6-7F2CD4702B84}" type="datetime1">
               <a:rPr lang="en-US" smtClean="0"/>
-              <a:t>3/26/2026</a:t>
+              <a:t>3/31/2026</a:t>
             </a:fld>
             <a:endParaRPr lang="en-US"/>
           </a:p>
@@ -13947,10 +13947,10 @@
           <p:nvPr/>
         </p:nvPicPr>
         <p:blipFill>
-          <a:blip r:embed="rId5">
+          <a:blip>
             <a:extLst>
               <a:ext uri="{96DAC541-7B7A-43D3-8B79-37D633B846F1}">
-                <asvg:svgBlip xmlns:asvg="http://schemas.microsoft.com/office/drawing/2016/SVG/main" r:embed="rId6"/>
+                <asvg:svgBlip xmlns:asvg="http://schemas.microsoft.com/office/drawing/2016/SVG/main" r:embed="rId5"/>
               </a:ext>
             </a:extLst>
           </a:blip>
@@ -14103,7 +14103,7 @@
           <p:nvPr/>
         </p:nvPicPr>
         <p:blipFill rotWithShape="1">
-          <a:blip r:embed="rId7">
+          <a:blip r:embed="rId6">
             <a:extLst>
               <a:ext uri="{28A0092B-C50C-407E-A947-70E740481C1C}">
                 <a14:useLocalDpi xmlns:a14="http://schemas.microsoft.com/office/drawing/2010/main" val="0"/>
@@ -21536,9 +21536,9 @@
           <a:lstStyle/>
           <a:p>
             <a:r>
-              <a:rPr lang="en-CA" sz="2000" dirty="0">
+              <a:rPr lang="en-CA" sz="2000" b="1" dirty="0">
                 <a:solidFill>
-                  <a:schemeClr val="bg1"/>
+                  <a:srgbClr val="FF0000"/>
                 </a:solidFill>
                 <a:hlinkClick r:id="rId5">
                   <a:extLst>
@@ -21550,9 +21550,9 @@
               </a:rPr>
               <a:t>https://skills.sh/</a:t>
             </a:r>
-            <a:endParaRPr lang="en-CA" sz="2000" dirty="0">
+            <a:endParaRPr lang="en-CA" sz="2000" b="1" dirty="0">
               <a:solidFill>
-                <a:schemeClr val="bg1"/>
+                <a:srgbClr val="FF0000"/>
               </a:solidFill>
             </a:endParaRPr>
           </a:p>
@@ -21636,9 +21636,9 @@
           <a:lstStyle/>
           <a:p>
             <a:r>
-              <a:rPr lang="en-CA" sz="2000" dirty="0">
+              <a:rPr lang="en-CA" sz="2000" b="1" dirty="0">
                 <a:solidFill>
-                  <a:srgbClr val="022911"/>
+                  <a:srgbClr val="FF0000"/>
                 </a:solidFill>
                 <a:hlinkClick r:id="rId7">
                   <a:extLst>
@@ -21650,9 +21650,9 @@
               </a:rPr>
               <a:t>https://www.skillhub.club/</a:t>
             </a:r>
-            <a:endParaRPr lang="en-CA" sz="2000" dirty="0">
+            <a:endParaRPr lang="en-CA" sz="2000" b="1" dirty="0">
               <a:solidFill>
-                <a:srgbClr val="022911"/>
+                <a:srgbClr val="FF0000"/>
               </a:solidFill>
             </a:endParaRPr>
           </a:p>
@@ -26466,7 +26466,99 @@
                 <a:ea typeface="Calibri" pitchFamily="34" charset="-122"/>
                 <a:cs typeface="Calibri" pitchFamily="34" charset="-120"/>
               </a:rPr>
-              <a:t>Plugins bundle skills, connectors, slash commands &amp; sub-agents into one package for a specific job function. No technical knowledge required to create them.</a:t>
+              <a:t>Plugins bundle </a:t>
+            </a:r>
+            <a:r>
+              <a:rPr lang="en-US" sz="1800" b="1" dirty="0">
+                <a:solidFill>
+                  <a:srgbClr val="FF0000"/>
+                </a:solidFill>
+                <a:latin typeface="Montserrat" panose="00000500000000000000" pitchFamily="2" charset="0"/>
+                <a:ea typeface="Calibri" pitchFamily="34" charset="-122"/>
+                <a:cs typeface="Calibri" pitchFamily="34" charset="-120"/>
+              </a:rPr>
+              <a:t>skills</a:t>
+            </a:r>
+            <a:r>
+              <a:rPr lang="en-US" sz="1800" dirty="0">
+                <a:latin typeface="Montserrat" panose="00000500000000000000" pitchFamily="2" charset="0"/>
+                <a:ea typeface="Calibri" pitchFamily="34" charset="-122"/>
+                <a:cs typeface="Calibri" pitchFamily="34" charset="-120"/>
+              </a:rPr>
+              <a:t>, </a:t>
+            </a:r>
+            <a:r>
+              <a:rPr lang="en-US" sz="1800" b="1" dirty="0">
+                <a:solidFill>
+                  <a:srgbClr val="FF0000"/>
+                </a:solidFill>
+                <a:latin typeface="Montserrat" panose="00000500000000000000" pitchFamily="2" charset="0"/>
+                <a:ea typeface="Calibri" pitchFamily="34" charset="-122"/>
+                <a:cs typeface="Calibri" pitchFamily="34" charset="-120"/>
+              </a:rPr>
+              <a:t>connectors</a:t>
+            </a:r>
+            <a:r>
+              <a:rPr lang="en-US" sz="1800" dirty="0">
+                <a:latin typeface="Montserrat" panose="00000500000000000000" pitchFamily="2" charset="0"/>
+                <a:ea typeface="Calibri" pitchFamily="34" charset="-122"/>
+                <a:cs typeface="Calibri" pitchFamily="34" charset="-120"/>
+              </a:rPr>
+              <a:t>, </a:t>
+            </a:r>
+            <a:r>
+              <a:rPr lang="en-US" sz="1800" b="1" dirty="0">
+                <a:solidFill>
+                  <a:srgbClr val="FF0000"/>
+                </a:solidFill>
+                <a:latin typeface="Montserrat" panose="00000500000000000000" pitchFamily="2" charset="0"/>
+                <a:ea typeface="Calibri" pitchFamily="34" charset="-122"/>
+                <a:cs typeface="Calibri" pitchFamily="34" charset="-120"/>
+              </a:rPr>
+              <a:t>slash commands</a:t>
+            </a:r>
+            <a:r>
+              <a:rPr lang="en-US" sz="1800" dirty="0">
+                <a:latin typeface="Montserrat" panose="00000500000000000000" pitchFamily="2" charset="0"/>
+                <a:ea typeface="Calibri" pitchFamily="34" charset="-122"/>
+                <a:cs typeface="Calibri" pitchFamily="34" charset="-120"/>
+              </a:rPr>
+              <a:t> &amp; </a:t>
+            </a:r>
+            <a:r>
+              <a:rPr lang="en-US" sz="1800" b="1" dirty="0">
+                <a:solidFill>
+                  <a:srgbClr val="FF0000"/>
+                </a:solidFill>
+                <a:latin typeface="Montserrat" panose="00000500000000000000" pitchFamily="2" charset="0"/>
+                <a:ea typeface="Calibri" pitchFamily="34" charset="-122"/>
+                <a:cs typeface="Calibri" pitchFamily="34" charset="-120"/>
+              </a:rPr>
+              <a:t>sub-agents</a:t>
+            </a:r>
+            <a:r>
+              <a:rPr lang="en-US" sz="1800" dirty="0">
+                <a:latin typeface="Montserrat" panose="00000500000000000000" pitchFamily="2" charset="0"/>
+                <a:ea typeface="Calibri" pitchFamily="34" charset="-122"/>
+                <a:cs typeface="Calibri" pitchFamily="34" charset="-120"/>
+              </a:rPr>
+              <a:t> into </a:t>
+            </a:r>
+            <a:r>
+              <a:rPr lang="en-US" sz="1800" b="1" dirty="0">
+                <a:latin typeface="Montserrat" panose="00000500000000000000" pitchFamily="2" charset="0"/>
+                <a:ea typeface="Calibri" pitchFamily="34" charset="-122"/>
+                <a:cs typeface="Calibri" pitchFamily="34" charset="-120"/>
+              </a:rPr>
+              <a:t>one package </a:t>
+            </a:r>
+            <a:r>
+              <a:rPr lang="en-US" sz="1800" dirty="0">
+                <a:latin typeface="Montserrat" panose="00000500000000000000" pitchFamily="2" charset="0"/>
+                <a:ea typeface="Calibri" pitchFamily="34" charset="-122"/>
+                <a:cs typeface="Calibri" pitchFamily="34" charset="-120"/>
+              </a:rPr>
+              <a:t>for a specific job function. No technical knowledge required to create them.</a:t>
             </a:r>
             <a:endParaRPr lang="en-US" sz="1800" dirty="0">
               <a:latin typeface="Montserrat" panose="00000500000000000000" pitchFamily="2" charset="0"/>

</xml_diff>